<commit_message>
Add M&A exercise: filled FinPro model for Bank 4 acquisition + deck slide
- docs/BOTB_MA_Model_Bank4.xlsx: official GSBC/FinPro M&A model populated
  with Q4/30 B021/B022/B550 data (Bank 1 buyer, Bank 4 target), $49.00
  all-stock offer, 30% cost saves, 150% credit mark, 2% CDI. All 10
  checklist metrics in the green range; no issues flagged.
- Deck: new slide 16 "The Next Barrel: Acquiring Bank 4" reporting the
  M&A outcome, scorecard, recommendation, and learnings (checklist #11).

Co-Authored-By: Claude Fable 5 <noreply@anthropic.com>
Claude-Session: https://claude.ai/code/session_014Vi1zhQEVZ7wyMF3rLmoNd
</commit_message>
<xml_diff>
--- a/docs/BOTB_Shareholder_Presentation.pptx
+++ b/docs/BOTB_Shareholder_Presentation.pptx
@@ -21,9 +21,10 @@
     <p:sldId id="269" r:id="rId15"/>
     <p:sldId id="270" r:id="rId16"/>
     <p:sldId id="271" r:id="rId17"/>
+    <p:sldId id="272" r:id="rId18"/>
   </p:sldIdLst>
   <p:notesMasterIdLst>
-    <p:notesMasterId r:id="rId18"/>
+    <p:notesMasterId r:id="rId19"/>
   </p:notesMasterIdLst>
   <p:sldSz cx="12192000" cy="6858000"/>
   <p:notesSz cx="6858000" cy="12192000"/>
@@ -2770,7 +2771,7 @@
           <a:p>
             <a:r>
               <a:rPr lang="en-US" dirty="0"/>
-              <a:t>Full team (30 sec + 5 min Q&amp;A). Crib sheet: (1) Why dilute at the bottom? The penalty regime cost more than the dilution; later raises priced far better. (2) Construction risk? Priced for it, reviewed it, walked it down before the cycle forced us. (3) Is FY30 repeatable? The margin and cost base are structural; we guide conservatively on purpose. (4) Why believe the numbers? Every figure is from the regulatory reports, unadjusted.</a:t>
+              <a:t>JS + AY (90 sec): We didn't just claim M&amp;A readiness — we ran the full FinPro exercise on our community. Bank 4 is the strategic fit: $684M of assets, 97% core deposits, and an 86% efficiency ratio that is a fixable flaw, not a franchise flaw — our operating discipline converts it into $6.2M of annual savings. At $49 all-stock we pay a fair 24.7% premium yet only 108% of tangible book, because they trade at 0.87x. Every FinPro gate is green: +25% cash EPS accretion, 8.4% book dilution earned back in 4 years, 8% pro-forma tangible capital. And the combined bank crosses $1.5B — the growth goal we declined to buy with wholesale leverage, achieved with a franchise instead. Q&amp;A crib: (1) Why not Bank 3? Stronger bank but B-rated funding profile and priced closer to book — less value to unlock. (2) Integration risk? Cost saves at 30% are mid-range of the 20–40% norm; credit marked at 150% of their allowance because their coverage is thin (63.5% of non-performers). (3) Management? Our team leads; their retail and consumer bench deepens ours. (4) Above 30% premium the deal fails dilution and earn-back gates — we walk.</a:t>
             </a:r>
             <a:endParaRPr lang="en-US" dirty="0"/>
           </a:p>
@@ -2794,6 +2795,94 @@
             <a:fld id="{F7021451-1387-4CA6-816F-3879F97B5CBC}" type="slidenum">
               <a:rPr lang="en-US"/>
               <a:t>16</a:t>
+            </a:fld>
+            <a:endParaRPr lang="en-US"/>
+          </a:p>
+        </p:txBody>
+      </p:sp>
+    </p:spTree>
+    <p:extLst>
+      <p:ext uri="{BB962C8B-B14F-4D97-AF65-F5344CB8AC3E}">
+        <p14:creationId xmlns:p14="http://schemas.microsoft.com/office/powerpoint/2010/main" val="1024086991"/>
+      </p:ext>
+    </p:extLst>
+  </p:cSld>
+  <p:clrMapOvr>
+    <a:masterClrMapping/>
+  </p:clrMapOvr>
+</p:notes>
+</file>
+
+<file path=ppt/notesSlides/notesSlide17.xml><?xml version="1.0" encoding="utf-8"?>
+<p:notes xmlns:a="http://schemas.openxmlformats.org/drawingml/2006/main" xmlns:r="http://schemas.openxmlformats.org/officeDocument/2006/relationships" xmlns:p="http://schemas.openxmlformats.org/presentationml/2006/main">
+  <p:cSld>
+    <p:spTree>
+      <p:nvGrpSpPr>
+        <p:cNvPr id="1" name=""/>
+        <p:cNvGrpSpPr/>
+        <p:nvPr/>
+      </p:nvGrpSpPr>
+      <p:grpSpPr>
+        <a:xfrm>
+          <a:off x="0" y="0"/>
+          <a:ext cx="0" cy="0"/>
+          <a:chOff x="0" y="0"/>
+          <a:chExt cx="0" cy="0"/>
+        </a:xfrm>
+      </p:grpSpPr>
+      <p:sp>
+        <p:nvSpPr>
+          <p:cNvPr id="2" name="Slide Image Placeholder 1"/>
+          <p:cNvSpPr>
+            <a:spLocks noGrp="1" noRot="1" noChangeAspect="1"/>
+          </p:cNvSpPr>
+          <p:nvPr>
+            <p:ph type="sldImg"/>
+          </p:nvPr>
+        </p:nvSpPr>
+        <p:spPr/>
+      </p:sp>
+      <p:sp>
+        <p:nvSpPr>
+          <p:cNvPr id="3" name="Notes Placeholder 2"/>
+          <p:cNvSpPr>
+            <a:spLocks noGrp="1"/>
+          </p:cNvSpPr>
+          <p:nvPr>
+            <p:ph type="body" idx="1"/>
+          </p:nvPr>
+        </p:nvSpPr>
+        <p:spPr/>
+        <p:txBody>
+          <a:bodyPr/>
+          <a:lstStyle/>
+          <a:p>
+            <a:r>
+              <a:rPr lang="en-US" dirty="0"/>
+              <a:t>Full team (30 sec + 5 min Q&amp;A). Crib sheet: (1) Why dilute at the bottom? The penalty regime cost more than the dilution; later raises priced far better. (2) Construction risk? Priced for it, reviewed it, walked it down before the cycle forced us. (3) Is FY30 repeatable? The margin and cost base are structural; we guide conservatively on purpose. (4) Why believe the numbers? Every figure is from the regulatory reports, unadjusted.</a:t>
+            </a:r>
+            <a:endParaRPr lang="en-US" dirty="0"/>
+          </a:p>
+        </p:txBody>
+      </p:sp>
+      <p:sp>
+        <p:nvSpPr>
+          <p:cNvPr id="4" name="Slide Number Placeholder 3"/>
+          <p:cNvSpPr>
+            <a:spLocks noGrp="1"/>
+          </p:cNvSpPr>
+          <p:nvPr>
+            <p:ph type="sldNum" sz="quarter" idx="10"/>
+          </p:nvPr>
+        </p:nvSpPr>
+        <p:spPr/>
+        <p:txBody>
+          <a:bodyPr/>
+          <a:lstStyle/>
+          <a:p>
+            <a:fld id="{F7021451-1387-4CA6-816F-3879F97B5CBC}" type="slidenum">
+              <a:rPr lang="en-US"/>
+              <a:t>17</a:t>
             </a:fld>
             <a:endParaRPr lang="en-US"/>
           </a:p>
@@ -9809,6 +9898,1603 @@
     <p:bg>
       <p:bgPr>
         <a:solidFill>
+          <a:srgbClr val="FFFFFF"/>
+        </a:solidFill>
+      </p:bgPr>
+    </p:bg>
+    <p:spTree>
+      <p:nvGrpSpPr>
+        <p:cNvPr id="1" name=""/>
+        <p:cNvGrpSpPr/>
+        <p:nvPr/>
+      </p:nvGrpSpPr>
+      <p:grpSpPr>
+        <a:xfrm>
+          <a:off x="0" y="0"/>
+          <a:ext cx="0" cy="0"/>
+          <a:chOff x="0" y="0"/>
+          <a:chExt cx="0" cy="0"/>
+        </a:xfrm>
+      </p:grpSpPr>
+      <p:sp>
+        <p:nvSpPr>
+          <p:cNvPr id="2" name="Text 0"/>
+          <p:cNvSpPr/>
+          <p:nvPr/>
+        </p:nvSpPr>
+        <p:spPr>
+          <a:xfrm>
+            <a:off x="548640" y="292608"/>
+            <a:ext cx="10515600" cy="292608"/>
+          </a:xfrm>
+          <a:prstGeom prst="rect">
+            <a:avLst/>
+          </a:prstGeom>
+          <a:noFill/>
+          <a:ln/>
+        </p:spPr>
+        <p:txBody>
+          <a:bodyPr wrap="square" lIns="0" tIns="0" rIns="0" bIns="0" rtlCol="0" anchor="ctr"/>
+          <a:lstStyle/>
+          <a:p>
+            <a:pPr indent="0" marL="0">
+              <a:buNone/>
+            </a:pPr>
+            <a:r>
+              <a:rPr lang="en-US" sz="1200" b="1" spc="200" kern="0" dirty="0">
+                <a:solidFill>
+                  <a:srgbClr val="B9791F"/>
+                </a:solidFill>
+                <a:latin typeface="Calibri" pitchFamily="34" charset="0"/>
+                <a:ea typeface="Calibri" pitchFamily="34" charset="-122"/>
+                <a:cs typeface="Calibri" pitchFamily="34" charset="-120"/>
+              </a:rPr>
+              <a:t>M&amp;A EXERCISE OUTCOME — OUR RECOMMENDATION TO SHAREHOLDERS</a:t>
+            </a:r>
+            <a:endParaRPr lang="en-US" sz="1200" dirty="0"/>
+          </a:p>
+        </p:txBody>
+      </p:sp>
+      <p:sp>
+        <p:nvSpPr>
+          <p:cNvPr id="3" name="Text 1"/>
+          <p:cNvSpPr/>
+          <p:nvPr/>
+        </p:nvSpPr>
+        <p:spPr>
+          <a:xfrm>
+            <a:off x="548640" y="530352"/>
+            <a:ext cx="11064240" cy="685800"/>
+          </a:xfrm>
+          <a:prstGeom prst="rect">
+            <a:avLst/>
+          </a:prstGeom>
+          <a:noFill/>
+          <a:ln/>
+        </p:spPr>
+        <p:txBody>
+          <a:bodyPr wrap="square" lIns="0" tIns="0" rIns="0" bIns="0" rtlCol="0" anchor="ctr"/>
+          <a:lstStyle/>
+          <a:p>
+            <a:pPr indent="0" marL="0">
+              <a:buNone/>
+            </a:pPr>
+            <a:r>
+              <a:rPr lang="en-US" sz="3200" b="1" dirty="0">
+                <a:solidFill>
+                  <a:srgbClr val="1F2A44"/>
+                </a:solidFill>
+                <a:latin typeface="Cambria" pitchFamily="34" charset="0"/>
+                <a:ea typeface="Cambria" pitchFamily="34" charset="-122"/>
+                <a:cs typeface="Cambria" pitchFamily="34" charset="-120"/>
+              </a:rPr>
+              <a:t>The Next Barrel: Acquiring Bank 4</a:t>
+            </a:r>
+            <a:endParaRPr lang="en-US" sz="3200" dirty="0"/>
+          </a:p>
+        </p:txBody>
+      </p:sp>
+      <p:sp>
+        <p:nvSpPr>
+          <p:cNvPr id="4" name="Shape 2"/>
+          <p:cNvSpPr/>
+          <p:nvPr/>
+        </p:nvSpPr>
+        <p:spPr>
+          <a:xfrm>
+            <a:off x="548640" y="1508760"/>
+            <a:ext cx="5074920" cy="3200400"/>
+          </a:xfrm>
+          <a:prstGeom prst="roundRect">
+            <a:avLst>
+              <a:gd name="adj" fmla="val 2286"/>
+            </a:avLst>
+          </a:prstGeom>
+          <a:solidFill>
+            <a:srgbClr val="F5F0E4"/>
+          </a:solidFill>
+          <a:ln/>
+        </p:spPr>
+      </p:sp>
+      <p:sp>
+        <p:nvSpPr>
+          <p:cNvPr id="5" name="Text 3"/>
+          <p:cNvSpPr/>
+          <p:nvPr/>
+        </p:nvSpPr>
+        <p:spPr>
+          <a:xfrm>
+            <a:off x="777240" y="1664208"/>
+            <a:ext cx="4572000" cy="274320"/>
+          </a:xfrm>
+          <a:prstGeom prst="rect">
+            <a:avLst/>
+          </a:prstGeom>
+          <a:noFill/>
+          <a:ln/>
+        </p:spPr>
+        <p:txBody>
+          <a:bodyPr wrap="square" lIns="0" tIns="0" rIns="0" bIns="0" rtlCol="0" anchor="ctr"/>
+          <a:lstStyle/>
+          <a:p>
+            <a:pPr indent="0" marL="0">
+              <a:buNone/>
+            </a:pPr>
+            <a:r>
+              <a:rPr lang="en-US" sz="1050" b="1" spc="200" kern="0" dirty="0">
+                <a:solidFill>
+                  <a:srgbClr val="B9791F"/>
+                </a:solidFill>
+                <a:latin typeface="Calibri" pitchFamily="34" charset="0"/>
+                <a:ea typeface="Calibri" pitchFamily="34" charset="-122"/>
+                <a:cs typeface="Calibri" pitchFamily="34" charset="-120"/>
+              </a:rPr>
+              <a:t>THE PROPOSED DEAL</a:t>
+            </a:r>
+            <a:endParaRPr lang="en-US" sz="1050" dirty="0"/>
+          </a:p>
+        </p:txBody>
+      </p:sp>
+      <p:sp>
+        <p:nvSpPr>
+          <p:cNvPr id="6" name="Text 4"/>
+          <p:cNvSpPr/>
+          <p:nvPr/>
+        </p:nvSpPr>
+        <p:spPr>
+          <a:xfrm>
+            <a:off x="777240" y="2011680"/>
+            <a:ext cx="1417320" cy="384048"/>
+          </a:xfrm>
+          <a:prstGeom prst="rect">
+            <a:avLst/>
+          </a:prstGeom>
+          <a:noFill/>
+          <a:ln/>
+        </p:spPr>
+        <p:txBody>
+          <a:bodyPr wrap="square" lIns="0" tIns="0" rIns="0" bIns="0" rtlCol="0" anchor="ctr"/>
+          <a:lstStyle/>
+          <a:p>
+            <a:pPr indent="0" marL="0">
+              <a:buNone/>
+            </a:pPr>
+            <a:r>
+              <a:rPr lang="en-US" sz="1100" b="1" dirty="0">
+                <a:solidFill>
+                  <a:srgbClr val="1F2A44"/>
+                </a:solidFill>
+                <a:latin typeface="Calibri" pitchFamily="34" charset="0"/>
+                <a:ea typeface="Calibri" pitchFamily="34" charset="-122"/>
+                <a:cs typeface="Calibri" pitchFamily="34" charset="-120"/>
+              </a:rPr>
+              <a:t>Offer</a:t>
+            </a:r>
+            <a:endParaRPr lang="en-US" sz="1100" dirty="0"/>
+          </a:p>
+        </p:txBody>
+      </p:sp>
+      <p:sp>
+        <p:nvSpPr>
+          <p:cNvPr id="7" name="Text 5"/>
+          <p:cNvSpPr/>
+          <p:nvPr/>
+        </p:nvSpPr>
+        <p:spPr>
+          <a:xfrm>
+            <a:off x="2240280" y="2011680"/>
+            <a:ext cx="3291840" cy="384048"/>
+          </a:xfrm>
+          <a:prstGeom prst="rect">
+            <a:avLst/>
+          </a:prstGeom>
+          <a:noFill/>
+          <a:ln/>
+        </p:spPr>
+        <p:txBody>
+          <a:bodyPr wrap="square" lIns="0" tIns="0" rIns="0" bIns="0" rtlCol="0" anchor="ctr"/>
+          <a:lstStyle/>
+          <a:p>
+            <a:pPr indent="0" marL="0">
+              <a:buNone/>
+            </a:pPr>
+            <a:r>
+              <a:rPr lang="en-US" sz="1100" dirty="0">
+                <a:solidFill>
+                  <a:srgbClr val="232733"/>
+                </a:solidFill>
+                <a:latin typeface="Calibri" pitchFamily="34" charset="0"/>
+                <a:ea typeface="Calibri" pitchFamily="34" charset="-122"/>
+                <a:cs typeface="Calibri" pitchFamily="34" charset="-120"/>
+              </a:rPr>
+              <a:t>$49.00 / share — 100% stock</a:t>
+            </a:r>
+            <a:endParaRPr lang="en-US" sz="1100" dirty="0"/>
+          </a:p>
+        </p:txBody>
+      </p:sp>
+      <p:sp>
+        <p:nvSpPr>
+          <p:cNvPr id="8" name="Text 6"/>
+          <p:cNvSpPr/>
+          <p:nvPr/>
+        </p:nvSpPr>
+        <p:spPr>
+          <a:xfrm>
+            <a:off x="777240" y="2441448"/>
+            <a:ext cx="1417320" cy="384048"/>
+          </a:xfrm>
+          <a:prstGeom prst="rect">
+            <a:avLst/>
+          </a:prstGeom>
+          <a:noFill/>
+          <a:ln/>
+        </p:spPr>
+        <p:txBody>
+          <a:bodyPr wrap="square" lIns="0" tIns="0" rIns="0" bIns="0" rtlCol="0" anchor="ctr"/>
+          <a:lstStyle/>
+          <a:p>
+            <a:pPr indent="0" marL="0">
+              <a:buNone/>
+            </a:pPr>
+            <a:r>
+              <a:rPr lang="en-US" sz="1100" b="1" dirty="0">
+                <a:solidFill>
+                  <a:srgbClr val="1F2A44"/>
+                </a:solidFill>
+                <a:latin typeface="Calibri" pitchFamily="34" charset="0"/>
+                <a:ea typeface="Calibri" pitchFamily="34" charset="-122"/>
+                <a:cs typeface="Calibri" pitchFamily="34" charset="-120"/>
+              </a:rPr>
+              <a:t>Premium</a:t>
+            </a:r>
+            <a:endParaRPr lang="en-US" sz="1100" dirty="0"/>
+          </a:p>
+        </p:txBody>
+      </p:sp>
+      <p:sp>
+        <p:nvSpPr>
+          <p:cNvPr id="9" name="Text 7"/>
+          <p:cNvSpPr/>
+          <p:nvPr/>
+        </p:nvSpPr>
+        <p:spPr>
+          <a:xfrm>
+            <a:off x="2240280" y="2441448"/>
+            <a:ext cx="3291840" cy="384048"/>
+          </a:xfrm>
+          <a:prstGeom prst="rect">
+            <a:avLst/>
+          </a:prstGeom>
+          <a:noFill/>
+          <a:ln/>
+        </p:spPr>
+        <p:txBody>
+          <a:bodyPr wrap="square" lIns="0" tIns="0" rIns="0" bIns="0" rtlCol="0" anchor="ctr"/>
+          <a:lstStyle/>
+          <a:p>
+            <a:pPr indent="0" marL="0">
+              <a:buNone/>
+            </a:pPr>
+            <a:r>
+              <a:rPr lang="en-US" sz="1100" dirty="0">
+                <a:solidFill>
+                  <a:srgbClr val="232733"/>
+                </a:solidFill>
+                <a:latin typeface="Calibri" pitchFamily="34" charset="0"/>
+                <a:ea typeface="Calibri" pitchFamily="34" charset="-122"/>
+                <a:cs typeface="Calibri" pitchFamily="34" charset="-120"/>
+              </a:rPr>
+              <a:t>24.7% over market · 108% of tangible book</a:t>
+            </a:r>
+            <a:endParaRPr lang="en-US" sz="1100" dirty="0"/>
+          </a:p>
+        </p:txBody>
+      </p:sp>
+      <p:sp>
+        <p:nvSpPr>
+          <p:cNvPr id="10" name="Text 8"/>
+          <p:cNvSpPr/>
+          <p:nvPr/>
+        </p:nvSpPr>
+        <p:spPr>
+          <a:xfrm>
+            <a:off x="777240" y="2871216"/>
+            <a:ext cx="1417320" cy="384048"/>
+          </a:xfrm>
+          <a:prstGeom prst="rect">
+            <a:avLst/>
+          </a:prstGeom>
+          <a:noFill/>
+          <a:ln/>
+        </p:spPr>
+        <p:txBody>
+          <a:bodyPr wrap="square" lIns="0" tIns="0" rIns="0" bIns="0" rtlCol="0" anchor="ctr"/>
+          <a:lstStyle/>
+          <a:p>
+            <a:pPr indent="0" marL="0">
+              <a:buNone/>
+            </a:pPr>
+            <a:r>
+              <a:rPr lang="en-US" sz="1100" b="1" dirty="0">
+                <a:solidFill>
+                  <a:srgbClr val="1F2A44"/>
+                </a:solidFill>
+                <a:latin typeface="Calibri" pitchFamily="34" charset="0"/>
+                <a:ea typeface="Calibri" pitchFamily="34" charset="-122"/>
+                <a:cs typeface="Calibri" pitchFamily="34" charset="-120"/>
+              </a:rPr>
+              <a:t>Deal value</a:t>
+            </a:r>
+            <a:endParaRPr lang="en-US" sz="1100" dirty="0"/>
+          </a:p>
+        </p:txBody>
+      </p:sp>
+      <p:sp>
+        <p:nvSpPr>
+          <p:cNvPr id="11" name="Text 9"/>
+          <p:cNvSpPr/>
+          <p:nvPr/>
+        </p:nvSpPr>
+        <p:spPr>
+          <a:xfrm>
+            <a:off x="2240280" y="2871216"/>
+            <a:ext cx="3291840" cy="384048"/>
+          </a:xfrm>
+          <a:prstGeom prst="rect">
+            <a:avLst/>
+          </a:prstGeom>
+          <a:noFill/>
+          <a:ln/>
+        </p:spPr>
+        <p:txBody>
+          <a:bodyPr wrap="square" lIns="0" tIns="0" rIns="0" bIns="0" rtlCol="0" anchor="ctr"/>
+          <a:lstStyle/>
+          <a:p>
+            <a:pPr indent="0" marL="0">
+              <a:buNone/>
+            </a:pPr>
+            <a:r>
+              <a:rPr lang="en-US" sz="1100" dirty="0">
+                <a:solidFill>
+                  <a:srgbClr val="232733"/>
+                </a:solidFill>
+                <a:latin typeface="Calibri" pitchFamily="34" charset="0"/>
+                <a:ea typeface="Calibri" pitchFamily="34" charset="-122"/>
+                <a:cs typeface="Calibri" pitchFamily="34" charset="-120"/>
+              </a:rPr>
+              <a:t>$57.3M · ~1.39M new shares issued</a:t>
+            </a:r>
+            <a:endParaRPr lang="en-US" sz="1100" dirty="0"/>
+          </a:p>
+        </p:txBody>
+      </p:sp>
+      <p:sp>
+        <p:nvSpPr>
+          <p:cNvPr id="12" name="Text 10"/>
+          <p:cNvSpPr/>
+          <p:nvPr/>
+        </p:nvSpPr>
+        <p:spPr>
+          <a:xfrm>
+            <a:off x="777240" y="3300984"/>
+            <a:ext cx="1417320" cy="384048"/>
+          </a:xfrm>
+          <a:prstGeom prst="rect">
+            <a:avLst/>
+          </a:prstGeom>
+          <a:noFill/>
+          <a:ln/>
+        </p:spPr>
+        <p:txBody>
+          <a:bodyPr wrap="square" lIns="0" tIns="0" rIns="0" bIns="0" rtlCol="0" anchor="ctr"/>
+          <a:lstStyle/>
+          <a:p>
+            <a:pPr indent="0" marL="0">
+              <a:buNone/>
+            </a:pPr>
+            <a:r>
+              <a:rPr lang="en-US" sz="1100" b="1" dirty="0">
+                <a:solidFill>
+                  <a:srgbClr val="1F2A44"/>
+                </a:solidFill>
+                <a:latin typeface="Calibri" pitchFamily="34" charset="0"/>
+                <a:ea typeface="Calibri" pitchFamily="34" charset="-122"/>
+                <a:cs typeface="Calibri" pitchFamily="34" charset="-120"/>
+              </a:rPr>
+              <a:t>Combined bank</a:t>
+            </a:r>
+            <a:endParaRPr lang="en-US" sz="1100" dirty="0"/>
+          </a:p>
+        </p:txBody>
+      </p:sp>
+      <p:sp>
+        <p:nvSpPr>
+          <p:cNvPr id="13" name="Text 11"/>
+          <p:cNvSpPr/>
+          <p:nvPr/>
+        </p:nvSpPr>
+        <p:spPr>
+          <a:xfrm>
+            <a:off x="2240280" y="3300984"/>
+            <a:ext cx="3291840" cy="384048"/>
+          </a:xfrm>
+          <a:prstGeom prst="rect">
+            <a:avLst/>
+          </a:prstGeom>
+          <a:noFill/>
+          <a:ln/>
+        </p:spPr>
+        <p:txBody>
+          <a:bodyPr wrap="square" lIns="0" tIns="0" rIns="0" bIns="0" rtlCol="0" anchor="ctr"/>
+          <a:lstStyle/>
+          <a:p>
+            <a:pPr indent="0" marL="0">
+              <a:buNone/>
+            </a:pPr>
+            <a:r>
+              <a:rPr lang="en-US" sz="1100" dirty="0">
+                <a:solidFill>
+                  <a:srgbClr val="232733"/>
+                </a:solidFill>
+                <a:latin typeface="Calibri" pitchFamily="34" charset="0"/>
+                <a:ea typeface="Calibri" pitchFamily="34" charset="-122"/>
+                <a:cs typeface="Calibri" pitchFamily="34" charset="-120"/>
+              </a:rPr>
+              <a:t>≈ $1.50B assets — the $1B goal, achieved</a:t>
+            </a:r>
+            <a:endParaRPr lang="en-US" sz="1100" dirty="0"/>
+          </a:p>
+        </p:txBody>
+      </p:sp>
+      <p:sp>
+        <p:nvSpPr>
+          <p:cNvPr id="14" name="Text 12"/>
+          <p:cNvSpPr/>
+          <p:nvPr/>
+        </p:nvSpPr>
+        <p:spPr>
+          <a:xfrm>
+            <a:off x="777240" y="3730752"/>
+            <a:ext cx="1417320" cy="384048"/>
+          </a:xfrm>
+          <a:prstGeom prst="rect">
+            <a:avLst/>
+          </a:prstGeom>
+          <a:noFill/>
+          <a:ln/>
+        </p:spPr>
+        <p:txBody>
+          <a:bodyPr wrap="square" lIns="0" tIns="0" rIns="0" bIns="0" rtlCol="0" anchor="ctr"/>
+          <a:lstStyle/>
+          <a:p>
+            <a:pPr indent="0" marL="0">
+              <a:buNone/>
+            </a:pPr>
+            <a:r>
+              <a:rPr lang="en-US" sz="1100" b="1" dirty="0">
+                <a:solidFill>
+                  <a:srgbClr val="1F2A44"/>
+                </a:solidFill>
+                <a:latin typeface="Calibri" pitchFamily="34" charset="0"/>
+                <a:ea typeface="Calibri" pitchFamily="34" charset="-122"/>
+                <a:cs typeface="Calibri" pitchFamily="34" charset="-120"/>
+              </a:rPr>
+              <a:t>Why Bank 4</a:t>
+            </a:r>
+            <a:endParaRPr lang="en-US" sz="1100" dirty="0"/>
+          </a:p>
+        </p:txBody>
+      </p:sp>
+      <p:sp>
+        <p:nvSpPr>
+          <p:cNvPr id="15" name="Text 13"/>
+          <p:cNvSpPr/>
+          <p:nvPr/>
+        </p:nvSpPr>
+        <p:spPr>
+          <a:xfrm>
+            <a:off x="2240280" y="3730752"/>
+            <a:ext cx="3291840" cy="384048"/>
+          </a:xfrm>
+          <a:prstGeom prst="rect">
+            <a:avLst/>
+          </a:prstGeom>
+          <a:noFill/>
+          <a:ln/>
+        </p:spPr>
+        <p:txBody>
+          <a:bodyPr wrap="square" lIns="0" tIns="0" rIns="0" bIns="0" rtlCol="0" anchor="ctr"/>
+          <a:lstStyle/>
+          <a:p>
+            <a:pPr indent="0" marL="0">
+              <a:buNone/>
+            </a:pPr>
+            <a:r>
+              <a:rPr lang="en-US" sz="1100" dirty="0">
+                <a:solidFill>
+                  <a:srgbClr val="232733"/>
+                </a:solidFill>
+                <a:latin typeface="Calibri" pitchFamily="34" charset="0"/>
+                <a:ea typeface="Calibri" pitchFamily="34" charset="-122"/>
+                <a:cs typeface="Calibri" pitchFamily="34" charset="-120"/>
+              </a:rPr>
+              <a:t>97% core deposits · fixable 86% efficiency</a:t>
+            </a:r>
+            <a:endParaRPr lang="en-US" sz="1100" dirty="0"/>
+          </a:p>
+        </p:txBody>
+      </p:sp>
+      <p:sp>
+        <p:nvSpPr>
+          <p:cNvPr id="16" name="Text 14"/>
+          <p:cNvSpPr/>
+          <p:nvPr/>
+        </p:nvSpPr>
+        <p:spPr>
+          <a:xfrm>
+            <a:off x="777240" y="4160520"/>
+            <a:ext cx="1417320" cy="384048"/>
+          </a:xfrm>
+          <a:prstGeom prst="rect">
+            <a:avLst/>
+          </a:prstGeom>
+          <a:noFill/>
+          <a:ln/>
+        </p:spPr>
+        <p:txBody>
+          <a:bodyPr wrap="square" lIns="0" tIns="0" rIns="0" bIns="0" rtlCol="0" anchor="ctr"/>
+          <a:lstStyle/>
+          <a:p>
+            <a:pPr indent="0" marL="0">
+              <a:buNone/>
+            </a:pPr>
+            <a:r>
+              <a:rPr lang="en-US" sz="1100" b="1" dirty="0">
+                <a:solidFill>
+                  <a:srgbClr val="1F2A44"/>
+                </a:solidFill>
+                <a:latin typeface="Calibri" pitchFamily="34" charset="0"/>
+                <a:ea typeface="Calibri" pitchFamily="34" charset="-122"/>
+                <a:cs typeface="Calibri" pitchFamily="34" charset="-120"/>
+              </a:rPr>
+              <a:t>Cost savings</a:t>
+            </a:r>
+            <a:endParaRPr lang="en-US" sz="1100" dirty="0"/>
+          </a:p>
+        </p:txBody>
+      </p:sp>
+      <p:sp>
+        <p:nvSpPr>
+          <p:cNvPr id="17" name="Text 15"/>
+          <p:cNvSpPr/>
+          <p:nvPr/>
+        </p:nvSpPr>
+        <p:spPr>
+          <a:xfrm>
+            <a:off x="2240280" y="4160520"/>
+            <a:ext cx="3291840" cy="384048"/>
+          </a:xfrm>
+          <a:prstGeom prst="rect">
+            <a:avLst/>
+          </a:prstGeom>
+          <a:noFill/>
+          <a:ln/>
+        </p:spPr>
+        <p:txBody>
+          <a:bodyPr wrap="square" lIns="0" tIns="0" rIns="0" bIns="0" rtlCol="0" anchor="ctr"/>
+          <a:lstStyle/>
+          <a:p>
+            <a:pPr indent="0" marL="0">
+              <a:buNone/>
+            </a:pPr>
+            <a:r>
+              <a:rPr lang="en-US" sz="1100" dirty="0">
+                <a:solidFill>
+                  <a:srgbClr val="232733"/>
+                </a:solidFill>
+                <a:latin typeface="Calibri" pitchFamily="34" charset="0"/>
+                <a:ea typeface="Calibri" pitchFamily="34" charset="-122"/>
+                <a:cs typeface="Calibri" pitchFamily="34" charset="-120"/>
+              </a:rPr>
+              <a:t>$6.2M / yr (30% of their expense base)</a:t>
+            </a:r>
+            <a:endParaRPr lang="en-US" sz="1100" dirty="0"/>
+          </a:p>
+        </p:txBody>
+      </p:sp>
+      <p:sp>
+        <p:nvSpPr>
+          <p:cNvPr id="18" name="Shape 16"/>
+          <p:cNvSpPr/>
+          <p:nvPr/>
+        </p:nvSpPr>
+        <p:spPr>
+          <a:xfrm>
+            <a:off x="5897880" y="1508760"/>
+            <a:ext cx="5715000" cy="3200400"/>
+          </a:xfrm>
+          <a:prstGeom prst="roundRect">
+            <a:avLst>
+              <a:gd name="adj" fmla="val 2286"/>
+            </a:avLst>
+          </a:prstGeom>
+          <a:solidFill>
+            <a:srgbClr val="EFF2EE"/>
+          </a:solidFill>
+          <a:ln/>
+        </p:spPr>
+      </p:sp>
+      <p:sp>
+        <p:nvSpPr>
+          <p:cNvPr id="19" name="Text 17"/>
+          <p:cNvSpPr/>
+          <p:nvPr/>
+        </p:nvSpPr>
+        <p:spPr>
+          <a:xfrm>
+            <a:off x="6126480" y="1664208"/>
+            <a:ext cx="5303520" cy="274320"/>
+          </a:xfrm>
+          <a:prstGeom prst="rect">
+            <a:avLst/>
+          </a:prstGeom>
+          <a:noFill/>
+          <a:ln/>
+        </p:spPr>
+        <p:txBody>
+          <a:bodyPr wrap="square" lIns="0" tIns="0" rIns="0" bIns="0" rtlCol="0" anchor="ctr"/>
+          <a:lstStyle/>
+          <a:p>
+            <a:pPr indent="0" marL="0">
+              <a:buNone/>
+            </a:pPr>
+            <a:r>
+              <a:rPr lang="en-US" sz="1050" b="1" spc="200" kern="0" dirty="0">
+                <a:solidFill>
+                  <a:srgbClr val="3E5C41"/>
+                </a:solidFill>
+                <a:latin typeface="Calibri" pitchFamily="34" charset="0"/>
+                <a:ea typeface="Calibri" pitchFamily="34" charset="-122"/>
+                <a:cs typeface="Calibri" pitchFamily="34" charset="-120"/>
+              </a:rPr>
+              <a:t>FINPRO M&amp;A MODEL — EVERY GATE PASSED</a:t>
+            </a:r>
+            <a:endParaRPr lang="en-US" sz="1050" dirty="0"/>
+          </a:p>
+        </p:txBody>
+      </p:sp>
+      <p:sp>
+        <p:nvSpPr>
+          <p:cNvPr id="20" name="Shape 18"/>
+          <p:cNvSpPr/>
+          <p:nvPr/>
+        </p:nvSpPr>
+        <p:spPr>
+          <a:xfrm>
+            <a:off x="6126480" y="2084832"/>
+            <a:ext cx="219456" cy="219456"/>
+          </a:xfrm>
+          <a:prstGeom prst="ellipse">
+            <a:avLst/>
+          </a:prstGeom>
+          <a:solidFill>
+            <a:srgbClr val="2E7D32"/>
+          </a:solidFill>
+          <a:ln/>
+        </p:spPr>
+      </p:sp>
+      <p:sp>
+        <p:nvSpPr>
+          <p:cNvPr id="21" name="Text 19"/>
+          <p:cNvSpPr/>
+          <p:nvPr/>
+        </p:nvSpPr>
+        <p:spPr>
+          <a:xfrm>
+            <a:off x="6446520" y="2011680"/>
+            <a:ext cx="2423160" cy="384048"/>
+          </a:xfrm>
+          <a:prstGeom prst="rect">
+            <a:avLst/>
+          </a:prstGeom>
+          <a:noFill/>
+          <a:ln/>
+        </p:spPr>
+        <p:txBody>
+          <a:bodyPr wrap="square" lIns="0" tIns="0" rIns="0" bIns="0" rtlCol="0" anchor="ctr"/>
+          <a:lstStyle/>
+          <a:p>
+            <a:pPr indent="0" marL="0">
+              <a:buNone/>
+            </a:pPr>
+            <a:r>
+              <a:rPr lang="en-US" sz="1100" b="1" dirty="0">
+                <a:solidFill>
+                  <a:srgbClr val="1F2A44"/>
+                </a:solidFill>
+                <a:latin typeface="Calibri" pitchFamily="34" charset="0"/>
+                <a:ea typeface="Calibri" pitchFamily="34" charset="-122"/>
+                <a:cs typeface="Calibri" pitchFamily="34" charset="-120"/>
+              </a:rPr>
+              <a:t>Cash EPS accretion</a:t>
+            </a:r>
+            <a:endParaRPr lang="en-US" sz="1100" dirty="0"/>
+          </a:p>
+        </p:txBody>
+      </p:sp>
+      <p:sp>
+        <p:nvSpPr>
+          <p:cNvPr id="22" name="Text 20"/>
+          <p:cNvSpPr/>
+          <p:nvPr/>
+        </p:nvSpPr>
+        <p:spPr>
+          <a:xfrm>
+            <a:off x="8869680" y="2011680"/>
+            <a:ext cx="1371600" cy="384048"/>
+          </a:xfrm>
+          <a:prstGeom prst="rect">
+            <a:avLst/>
+          </a:prstGeom>
+          <a:noFill/>
+          <a:ln/>
+        </p:spPr>
+        <p:txBody>
+          <a:bodyPr wrap="square" lIns="0" tIns="0" rIns="0" bIns="0" rtlCol="0" anchor="ctr"/>
+          <a:lstStyle/>
+          <a:p>
+            <a:pPr indent="0" marL="0">
+              <a:buNone/>
+            </a:pPr>
+            <a:r>
+              <a:rPr lang="en-US" sz="1100" b="1" dirty="0">
+                <a:solidFill>
+                  <a:srgbClr val="3E5C41"/>
+                </a:solidFill>
+                <a:latin typeface="Calibri" pitchFamily="34" charset="0"/>
+                <a:ea typeface="Calibri" pitchFamily="34" charset="-122"/>
+                <a:cs typeface="Calibri" pitchFamily="34" charset="-120"/>
+              </a:rPr>
+              <a:t>+$0.85 (+25%)</a:t>
+            </a:r>
+            <a:endParaRPr lang="en-US" sz="1100" dirty="0"/>
+          </a:p>
+        </p:txBody>
+      </p:sp>
+      <p:sp>
+        <p:nvSpPr>
+          <p:cNvPr id="23" name="Text 21"/>
+          <p:cNvSpPr/>
+          <p:nvPr/>
+        </p:nvSpPr>
+        <p:spPr>
+          <a:xfrm>
+            <a:off x="10195560" y="2011680"/>
+            <a:ext cx="1325880" cy="384048"/>
+          </a:xfrm>
+          <a:prstGeom prst="rect">
+            <a:avLst/>
+          </a:prstGeom>
+          <a:noFill/>
+          <a:ln/>
+        </p:spPr>
+        <p:txBody>
+          <a:bodyPr wrap="square" lIns="0" tIns="0" rIns="0" bIns="0" rtlCol="0" anchor="ctr"/>
+          <a:lstStyle/>
+          <a:p>
+            <a:pPr indent="0" marL="0">
+              <a:buNone/>
+            </a:pPr>
+            <a:r>
+              <a:rPr lang="en-US" sz="950" dirty="0">
+                <a:solidFill>
+                  <a:srgbClr val="6E7480"/>
+                </a:solidFill>
+                <a:latin typeface="Calibri" pitchFamily="34" charset="0"/>
+                <a:ea typeface="Calibri" pitchFamily="34" charset="-122"/>
+                <a:cs typeface="Calibri" pitchFamily="34" charset="-120"/>
+              </a:rPr>
+              <a:t>must be positive</a:t>
+            </a:r>
+            <a:endParaRPr lang="en-US" sz="950" dirty="0"/>
+          </a:p>
+        </p:txBody>
+      </p:sp>
+      <p:sp>
+        <p:nvSpPr>
+          <p:cNvPr id="24" name="Shape 22"/>
+          <p:cNvSpPr/>
+          <p:nvPr/>
+        </p:nvSpPr>
+        <p:spPr>
+          <a:xfrm>
+            <a:off x="6126480" y="2514600"/>
+            <a:ext cx="219456" cy="219456"/>
+          </a:xfrm>
+          <a:prstGeom prst="ellipse">
+            <a:avLst/>
+          </a:prstGeom>
+          <a:solidFill>
+            <a:srgbClr val="2E7D32"/>
+          </a:solidFill>
+          <a:ln/>
+        </p:spPr>
+      </p:sp>
+      <p:sp>
+        <p:nvSpPr>
+          <p:cNvPr id="25" name="Text 23"/>
+          <p:cNvSpPr/>
+          <p:nvPr/>
+        </p:nvSpPr>
+        <p:spPr>
+          <a:xfrm>
+            <a:off x="6446520" y="2441448"/>
+            <a:ext cx="2423160" cy="384048"/>
+          </a:xfrm>
+          <a:prstGeom prst="rect">
+            <a:avLst/>
+          </a:prstGeom>
+          <a:noFill/>
+          <a:ln/>
+        </p:spPr>
+        <p:txBody>
+          <a:bodyPr wrap="square" lIns="0" tIns="0" rIns="0" bIns="0" rtlCol="0" anchor="ctr"/>
+          <a:lstStyle/>
+          <a:p>
+            <a:pPr indent="0" marL="0">
+              <a:buNone/>
+            </a:pPr>
+            <a:r>
+              <a:rPr lang="en-US" sz="1100" b="1" dirty="0">
+                <a:solidFill>
+                  <a:srgbClr val="1F2A44"/>
+                </a:solidFill>
+                <a:latin typeface="Calibri" pitchFamily="34" charset="0"/>
+                <a:ea typeface="Calibri" pitchFamily="34" charset="-122"/>
+                <a:cs typeface="Calibri" pitchFamily="34" charset="-120"/>
+              </a:rPr>
+              <a:t>Tangible book dilution</a:t>
+            </a:r>
+            <a:endParaRPr lang="en-US" sz="1100" dirty="0"/>
+          </a:p>
+        </p:txBody>
+      </p:sp>
+      <p:sp>
+        <p:nvSpPr>
+          <p:cNvPr id="26" name="Text 24"/>
+          <p:cNvSpPr/>
+          <p:nvPr/>
+        </p:nvSpPr>
+        <p:spPr>
+          <a:xfrm>
+            <a:off x="8869680" y="2441448"/>
+            <a:ext cx="1371600" cy="384048"/>
+          </a:xfrm>
+          <a:prstGeom prst="rect">
+            <a:avLst/>
+          </a:prstGeom>
+          <a:noFill/>
+          <a:ln/>
+        </p:spPr>
+        <p:txBody>
+          <a:bodyPr wrap="square" lIns="0" tIns="0" rIns="0" bIns="0" rtlCol="0" anchor="ctr"/>
+          <a:lstStyle/>
+          <a:p>
+            <a:pPr indent="0" marL="0">
+              <a:buNone/>
+            </a:pPr>
+            <a:r>
+              <a:rPr lang="en-US" sz="1100" b="1" dirty="0">
+                <a:solidFill>
+                  <a:srgbClr val="3E5C41"/>
+                </a:solidFill>
+                <a:latin typeface="Calibri" pitchFamily="34" charset="0"/>
+                <a:ea typeface="Calibri" pitchFamily="34" charset="-122"/>
+                <a:cs typeface="Calibri" pitchFamily="34" charset="-120"/>
+              </a:rPr>
+              <a:t>−8.4%</a:t>
+            </a:r>
+            <a:endParaRPr lang="en-US" sz="1100" dirty="0"/>
+          </a:p>
+        </p:txBody>
+      </p:sp>
+      <p:sp>
+        <p:nvSpPr>
+          <p:cNvPr id="27" name="Text 25"/>
+          <p:cNvSpPr/>
+          <p:nvPr/>
+        </p:nvSpPr>
+        <p:spPr>
+          <a:xfrm>
+            <a:off x="10195560" y="2441448"/>
+            <a:ext cx="1325880" cy="384048"/>
+          </a:xfrm>
+          <a:prstGeom prst="rect">
+            <a:avLst/>
+          </a:prstGeom>
+          <a:noFill/>
+          <a:ln/>
+        </p:spPr>
+        <p:txBody>
+          <a:bodyPr wrap="square" lIns="0" tIns="0" rIns="0" bIns="0" rtlCol="0" anchor="ctr"/>
+          <a:lstStyle/>
+          <a:p>
+            <a:pPr indent="0" marL="0">
+              <a:buNone/>
+            </a:pPr>
+            <a:r>
+              <a:rPr lang="en-US" sz="950" dirty="0">
+                <a:solidFill>
+                  <a:srgbClr val="6E7480"/>
+                </a:solidFill>
+                <a:latin typeface="Calibri" pitchFamily="34" charset="0"/>
+                <a:ea typeface="Calibri" pitchFamily="34" charset="-122"/>
+                <a:cs typeface="Calibri" pitchFamily="34" charset="-120"/>
+              </a:rPr>
+              <a:t>limit −10%</a:t>
+            </a:r>
+            <a:endParaRPr lang="en-US" sz="950" dirty="0"/>
+          </a:p>
+        </p:txBody>
+      </p:sp>
+      <p:sp>
+        <p:nvSpPr>
+          <p:cNvPr id="28" name="Shape 26"/>
+          <p:cNvSpPr/>
+          <p:nvPr/>
+        </p:nvSpPr>
+        <p:spPr>
+          <a:xfrm>
+            <a:off x="6126480" y="2944368"/>
+            <a:ext cx="219456" cy="219456"/>
+          </a:xfrm>
+          <a:prstGeom prst="ellipse">
+            <a:avLst/>
+          </a:prstGeom>
+          <a:solidFill>
+            <a:srgbClr val="2E7D32"/>
+          </a:solidFill>
+          <a:ln/>
+        </p:spPr>
+      </p:sp>
+      <p:sp>
+        <p:nvSpPr>
+          <p:cNvPr id="29" name="Text 27"/>
+          <p:cNvSpPr/>
+          <p:nvPr/>
+        </p:nvSpPr>
+        <p:spPr>
+          <a:xfrm>
+            <a:off x="6446520" y="2871216"/>
+            <a:ext cx="2423160" cy="384048"/>
+          </a:xfrm>
+          <a:prstGeom prst="rect">
+            <a:avLst/>
+          </a:prstGeom>
+          <a:noFill/>
+          <a:ln/>
+        </p:spPr>
+        <p:txBody>
+          <a:bodyPr wrap="square" lIns="0" tIns="0" rIns="0" bIns="0" rtlCol="0" anchor="ctr"/>
+          <a:lstStyle/>
+          <a:p>
+            <a:pPr indent="0" marL="0">
+              <a:buNone/>
+            </a:pPr>
+            <a:r>
+              <a:rPr lang="en-US" sz="1100" b="1" dirty="0">
+                <a:solidFill>
+                  <a:srgbClr val="1F2A44"/>
+                </a:solidFill>
+                <a:latin typeface="Calibri" pitchFamily="34" charset="0"/>
+                <a:ea typeface="Calibri" pitchFamily="34" charset="-122"/>
+                <a:cs typeface="Calibri" pitchFamily="34" charset="-120"/>
+              </a:rPr>
+              <a:t>Earn-back period</a:t>
+            </a:r>
+            <a:endParaRPr lang="en-US" sz="1100" dirty="0"/>
+          </a:p>
+        </p:txBody>
+      </p:sp>
+      <p:sp>
+        <p:nvSpPr>
+          <p:cNvPr id="30" name="Text 28"/>
+          <p:cNvSpPr/>
+          <p:nvPr/>
+        </p:nvSpPr>
+        <p:spPr>
+          <a:xfrm>
+            <a:off x="8869680" y="2871216"/>
+            <a:ext cx="1371600" cy="384048"/>
+          </a:xfrm>
+          <a:prstGeom prst="rect">
+            <a:avLst/>
+          </a:prstGeom>
+          <a:noFill/>
+          <a:ln/>
+        </p:spPr>
+        <p:txBody>
+          <a:bodyPr wrap="square" lIns="0" tIns="0" rIns="0" bIns="0" rtlCol="0" anchor="ctr"/>
+          <a:lstStyle/>
+          <a:p>
+            <a:pPr indent="0" marL="0">
+              <a:buNone/>
+            </a:pPr>
+            <a:r>
+              <a:rPr lang="en-US" sz="1100" b="1" dirty="0">
+                <a:solidFill>
+                  <a:srgbClr val="3E5C41"/>
+                </a:solidFill>
+                <a:latin typeface="Calibri" pitchFamily="34" charset="0"/>
+                <a:ea typeface="Calibri" pitchFamily="34" charset="-122"/>
+                <a:cs typeface="Calibri" pitchFamily="34" charset="-120"/>
+              </a:rPr>
+              <a:t>4.0 years</a:t>
+            </a:r>
+            <a:endParaRPr lang="en-US" sz="1100" dirty="0"/>
+          </a:p>
+        </p:txBody>
+      </p:sp>
+      <p:sp>
+        <p:nvSpPr>
+          <p:cNvPr id="31" name="Text 29"/>
+          <p:cNvSpPr/>
+          <p:nvPr/>
+        </p:nvSpPr>
+        <p:spPr>
+          <a:xfrm>
+            <a:off x="10195560" y="2871216"/>
+            <a:ext cx="1325880" cy="384048"/>
+          </a:xfrm>
+          <a:prstGeom prst="rect">
+            <a:avLst/>
+          </a:prstGeom>
+          <a:noFill/>
+          <a:ln/>
+        </p:spPr>
+        <p:txBody>
+          <a:bodyPr wrap="square" lIns="0" tIns="0" rIns="0" bIns="0" rtlCol="0" anchor="ctr"/>
+          <a:lstStyle/>
+          <a:p>
+            <a:pPr indent="0" marL="0">
+              <a:buNone/>
+            </a:pPr>
+            <a:r>
+              <a:rPr lang="en-US" sz="950" dirty="0">
+                <a:solidFill>
+                  <a:srgbClr val="6E7480"/>
+                </a:solidFill>
+                <a:latin typeface="Calibri" pitchFamily="34" charset="0"/>
+                <a:ea typeface="Calibri" pitchFamily="34" charset="-122"/>
+                <a:cs typeface="Calibri" pitchFamily="34" charset="-120"/>
+              </a:rPr>
+              <a:t>limit 5 years</a:t>
+            </a:r>
+            <a:endParaRPr lang="en-US" sz="950" dirty="0"/>
+          </a:p>
+        </p:txBody>
+      </p:sp>
+      <p:sp>
+        <p:nvSpPr>
+          <p:cNvPr id="32" name="Shape 30"/>
+          <p:cNvSpPr/>
+          <p:nvPr/>
+        </p:nvSpPr>
+        <p:spPr>
+          <a:xfrm>
+            <a:off x="6126480" y="3374136"/>
+            <a:ext cx="219456" cy="219456"/>
+          </a:xfrm>
+          <a:prstGeom prst="ellipse">
+            <a:avLst/>
+          </a:prstGeom>
+          <a:solidFill>
+            <a:srgbClr val="2E7D32"/>
+          </a:solidFill>
+          <a:ln/>
+        </p:spPr>
+      </p:sp>
+      <p:sp>
+        <p:nvSpPr>
+          <p:cNvPr id="33" name="Text 31"/>
+          <p:cNvSpPr/>
+          <p:nvPr/>
+        </p:nvSpPr>
+        <p:spPr>
+          <a:xfrm>
+            <a:off x="6446520" y="3300984"/>
+            <a:ext cx="2423160" cy="384048"/>
+          </a:xfrm>
+          <a:prstGeom prst="rect">
+            <a:avLst/>
+          </a:prstGeom>
+          <a:noFill/>
+          <a:ln/>
+        </p:spPr>
+        <p:txBody>
+          <a:bodyPr wrap="square" lIns="0" tIns="0" rIns="0" bIns="0" rtlCol="0" anchor="ctr"/>
+          <a:lstStyle/>
+          <a:p>
+            <a:pPr indent="0" marL="0">
+              <a:buNone/>
+            </a:pPr>
+            <a:r>
+              <a:rPr lang="en-US" sz="1100" b="1" dirty="0">
+                <a:solidFill>
+                  <a:srgbClr val="1F2A44"/>
+                </a:solidFill>
+                <a:latin typeface="Calibri" pitchFamily="34" charset="0"/>
+                <a:ea typeface="Calibri" pitchFamily="34" charset="-122"/>
+                <a:cs typeface="Calibri" pitchFamily="34" charset="-120"/>
+              </a:rPr>
+              <a:t>Pro-forma TCE / TA</a:t>
+            </a:r>
+            <a:endParaRPr lang="en-US" sz="1100" dirty="0"/>
+          </a:p>
+        </p:txBody>
+      </p:sp>
+      <p:sp>
+        <p:nvSpPr>
+          <p:cNvPr id="34" name="Text 32"/>
+          <p:cNvSpPr/>
+          <p:nvPr/>
+        </p:nvSpPr>
+        <p:spPr>
+          <a:xfrm>
+            <a:off x="8869680" y="3300984"/>
+            <a:ext cx="1371600" cy="384048"/>
+          </a:xfrm>
+          <a:prstGeom prst="rect">
+            <a:avLst/>
+          </a:prstGeom>
+          <a:noFill/>
+          <a:ln/>
+        </p:spPr>
+        <p:txBody>
+          <a:bodyPr wrap="square" lIns="0" tIns="0" rIns="0" bIns="0" rtlCol="0" anchor="ctr"/>
+          <a:lstStyle/>
+          <a:p>
+            <a:pPr indent="0" marL="0">
+              <a:buNone/>
+            </a:pPr>
+            <a:r>
+              <a:rPr lang="en-US" sz="1100" b="1" dirty="0">
+                <a:solidFill>
+                  <a:srgbClr val="3E5C41"/>
+                </a:solidFill>
+                <a:latin typeface="Calibri" pitchFamily="34" charset="0"/>
+                <a:ea typeface="Calibri" pitchFamily="34" charset="-122"/>
+                <a:cs typeface="Calibri" pitchFamily="34" charset="-120"/>
+              </a:rPr>
+              <a:t>8.0%</a:t>
+            </a:r>
+            <a:endParaRPr lang="en-US" sz="1100" dirty="0"/>
+          </a:p>
+        </p:txBody>
+      </p:sp>
+      <p:sp>
+        <p:nvSpPr>
+          <p:cNvPr id="35" name="Text 33"/>
+          <p:cNvSpPr/>
+          <p:nvPr/>
+        </p:nvSpPr>
+        <p:spPr>
+          <a:xfrm>
+            <a:off x="10195560" y="3300984"/>
+            <a:ext cx="1325880" cy="384048"/>
+          </a:xfrm>
+          <a:prstGeom prst="rect">
+            <a:avLst/>
+          </a:prstGeom>
+          <a:noFill/>
+          <a:ln/>
+        </p:spPr>
+        <p:txBody>
+          <a:bodyPr wrap="square" lIns="0" tIns="0" rIns="0" bIns="0" rtlCol="0" anchor="ctr"/>
+          <a:lstStyle/>
+          <a:p>
+            <a:pPr indent="0" marL="0">
+              <a:buNone/>
+            </a:pPr>
+            <a:r>
+              <a:rPr lang="en-US" sz="950" dirty="0">
+                <a:solidFill>
+                  <a:srgbClr val="6E7480"/>
+                </a:solidFill>
+                <a:latin typeface="Calibri" pitchFamily="34" charset="0"/>
+                <a:ea typeface="Calibri" pitchFamily="34" charset="-122"/>
+                <a:cs typeface="Calibri" pitchFamily="34" charset="-120"/>
+              </a:rPr>
+              <a:t>minimum 6%</a:t>
+            </a:r>
+            <a:endParaRPr lang="en-US" sz="950" dirty="0"/>
+          </a:p>
+        </p:txBody>
+      </p:sp>
+      <p:sp>
+        <p:nvSpPr>
+          <p:cNvPr id="36" name="Shape 34"/>
+          <p:cNvSpPr/>
+          <p:nvPr/>
+        </p:nvSpPr>
+        <p:spPr>
+          <a:xfrm>
+            <a:off x="6126480" y="3803904"/>
+            <a:ext cx="219456" cy="219456"/>
+          </a:xfrm>
+          <a:prstGeom prst="ellipse">
+            <a:avLst/>
+          </a:prstGeom>
+          <a:solidFill>
+            <a:srgbClr val="2E7D32"/>
+          </a:solidFill>
+          <a:ln/>
+        </p:spPr>
+      </p:sp>
+      <p:sp>
+        <p:nvSpPr>
+          <p:cNvPr id="37" name="Text 35"/>
+          <p:cNvSpPr/>
+          <p:nvPr/>
+        </p:nvSpPr>
+        <p:spPr>
+          <a:xfrm>
+            <a:off x="6446520" y="3730752"/>
+            <a:ext cx="2423160" cy="384048"/>
+          </a:xfrm>
+          <a:prstGeom prst="rect">
+            <a:avLst/>
+          </a:prstGeom>
+          <a:noFill/>
+          <a:ln/>
+        </p:spPr>
+        <p:txBody>
+          <a:bodyPr wrap="square" lIns="0" tIns="0" rIns="0" bIns="0" rtlCol="0" anchor="ctr"/>
+          <a:lstStyle/>
+          <a:p>
+            <a:pPr indent="0" marL="0">
+              <a:buNone/>
+            </a:pPr>
+            <a:r>
+              <a:rPr lang="en-US" sz="1100" b="1" dirty="0">
+                <a:solidFill>
+                  <a:srgbClr val="1F2A44"/>
+                </a:solidFill>
+                <a:latin typeface="Calibri" pitchFamily="34" charset="0"/>
+                <a:ea typeface="Calibri" pitchFamily="34" charset="-122"/>
+                <a:cs typeface="Calibri" pitchFamily="34" charset="-120"/>
+              </a:rPr>
+              <a:t>Buyer currency (P/TBV)</a:t>
+            </a:r>
+            <a:endParaRPr lang="en-US" sz="1100" dirty="0"/>
+          </a:p>
+        </p:txBody>
+      </p:sp>
+      <p:sp>
+        <p:nvSpPr>
+          <p:cNvPr id="38" name="Text 36"/>
+          <p:cNvSpPr/>
+          <p:nvPr/>
+        </p:nvSpPr>
+        <p:spPr>
+          <a:xfrm>
+            <a:off x="8869680" y="3730752"/>
+            <a:ext cx="1371600" cy="384048"/>
+          </a:xfrm>
+          <a:prstGeom prst="rect">
+            <a:avLst/>
+          </a:prstGeom>
+          <a:noFill/>
+          <a:ln/>
+        </p:spPr>
+        <p:txBody>
+          <a:bodyPr wrap="square" lIns="0" tIns="0" rIns="0" bIns="0" rtlCol="0" anchor="ctr"/>
+          <a:lstStyle/>
+          <a:p>
+            <a:pPr indent="0" marL="0">
+              <a:buNone/>
+            </a:pPr>
+            <a:r>
+              <a:rPr lang="en-US" sz="1100" b="1" dirty="0">
+                <a:solidFill>
+                  <a:srgbClr val="3E5C41"/>
+                </a:solidFill>
+                <a:latin typeface="Calibri" pitchFamily="34" charset="0"/>
+                <a:ea typeface="Calibri" pitchFamily="34" charset="-122"/>
+                <a:cs typeface="Calibri" pitchFamily="34" charset="-120"/>
+              </a:rPr>
+              <a:t>103%</a:t>
+            </a:r>
+            <a:endParaRPr lang="en-US" sz="1100" dirty="0"/>
+          </a:p>
+        </p:txBody>
+      </p:sp>
+      <p:sp>
+        <p:nvSpPr>
+          <p:cNvPr id="39" name="Text 37"/>
+          <p:cNvSpPr/>
+          <p:nvPr/>
+        </p:nvSpPr>
+        <p:spPr>
+          <a:xfrm>
+            <a:off x="10195560" y="3730752"/>
+            <a:ext cx="1325880" cy="384048"/>
+          </a:xfrm>
+          <a:prstGeom prst="rect">
+            <a:avLst/>
+          </a:prstGeom>
+          <a:noFill/>
+          <a:ln/>
+        </p:spPr>
+        <p:txBody>
+          <a:bodyPr wrap="square" lIns="0" tIns="0" rIns="0" bIns="0" rtlCol="0" anchor="ctr"/>
+          <a:lstStyle/>
+          <a:p>
+            <a:pPr indent="0" marL="0">
+              <a:buNone/>
+            </a:pPr>
+            <a:r>
+              <a:rPr lang="en-US" sz="950" dirty="0">
+                <a:solidFill>
+                  <a:srgbClr val="6E7480"/>
+                </a:solidFill>
+                <a:latin typeface="Calibri" pitchFamily="34" charset="0"/>
+                <a:ea typeface="Calibri" pitchFamily="34" charset="-122"/>
+                <a:cs typeface="Calibri" pitchFamily="34" charset="-120"/>
+              </a:rPr>
+              <a:t>must exceed 100%</a:t>
+            </a:r>
+            <a:endParaRPr lang="en-US" sz="950" dirty="0"/>
+          </a:p>
+        </p:txBody>
+      </p:sp>
+      <p:sp>
+        <p:nvSpPr>
+          <p:cNvPr id="40" name="Shape 38"/>
+          <p:cNvSpPr/>
+          <p:nvPr/>
+        </p:nvSpPr>
+        <p:spPr>
+          <a:xfrm>
+            <a:off x="6126480" y="4233672"/>
+            <a:ext cx="219456" cy="219456"/>
+          </a:xfrm>
+          <a:prstGeom prst="ellipse">
+            <a:avLst/>
+          </a:prstGeom>
+          <a:solidFill>
+            <a:srgbClr val="2E7D32"/>
+          </a:solidFill>
+          <a:ln/>
+        </p:spPr>
+      </p:sp>
+      <p:sp>
+        <p:nvSpPr>
+          <p:cNvPr id="41" name="Text 39"/>
+          <p:cNvSpPr/>
+          <p:nvPr/>
+        </p:nvSpPr>
+        <p:spPr>
+          <a:xfrm>
+            <a:off x="6446520" y="4160520"/>
+            <a:ext cx="2423160" cy="384048"/>
+          </a:xfrm>
+          <a:prstGeom prst="rect">
+            <a:avLst/>
+          </a:prstGeom>
+          <a:noFill/>
+          <a:ln/>
+        </p:spPr>
+        <p:txBody>
+          <a:bodyPr wrap="square" lIns="0" tIns="0" rIns="0" bIns="0" rtlCol="0" anchor="ctr"/>
+          <a:lstStyle/>
+          <a:p>
+            <a:pPr indent="0" marL="0">
+              <a:buNone/>
+            </a:pPr>
+            <a:r>
+              <a:rPr lang="en-US" sz="1100" b="1" dirty="0">
+                <a:solidFill>
+                  <a:srgbClr val="1F2A44"/>
+                </a:solidFill>
+                <a:latin typeface="Calibri" pitchFamily="34" charset="0"/>
+                <a:ea typeface="Calibri" pitchFamily="34" charset="-122"/>
+                <a:cs typeface="Calibri" pitchFamily="34" charset="-120"/>
+              </a:rPr>
+              <a:t>Combined CAMELS profile</a:t>
+            </a:r>
+            <a:endParaRPr lang="en-US" sz="1100" dirty="0"/>
+          </a:p>
+        </p:txBody>
+      </p:sp>
+      <p:sp>
+        <p:nvSpPr>
+          <p:cNvPr id="42" name="Text 40"/>
+          <p:cNvSpPr/>
+          <p:nvPr/>
+        </p:nvSpPr>
+        <p:spPr>
+          <a:xfrm>
+            <a:off x="8869680" y="4160520"/>
+            <a:ext cx="1371600" cy="384048"/>
+          </a:xfrm>
+          <a:prstGeom prst="rect">
+            <a:avLst/>
+          </a:prstGeom>
+          <a:noFill/>
+          <a:ln/>
+        </p:spPr>
+        <p:txBody>
+          <a:bodyPr wrap="square" lIns="0" tIns="0" rIns="0" bIns="0" rtlCol="0" anchor="ctr"/>
+          <a:lstStyle/>
+          <a:p>
+            <a:pPr indent="0" marL="0">
+              <a:buNone/>
+            </a:pPr>
+            <a:r>
+              <a:rPr lang="en-US" sz="1100" b="1" dirty="0">
+                <a:solidFill>
+                  <a:srgbClr val="3E5C41"/>
+                </a:solidFill>
+                <a:latin typeface="Calibri" pitchFamily="34" charset="0"/>
+                <a:ea typeface="Calibri" pitchFamily="34" charset="-122"/>
+                <a:cs typeface="Calibri" pitchFamily="34" charset="-120"/>
+              </a:rPr>
+              <a:t>2-rated buyer</a:t>
+            </a:r>
+            <a:endParaRPr lang="en-US" sz="1100" dirty="0"/>
+          </a:p>
+        </p:txBody>
+      </p:sp>
+      <p:sp>
+        <p:nvSpPr>
+          <p:cNvPr id="43" name="Text 41"/>
+          <p:cNvSpPr/>
+          <p:nvPr/>
+        </p:nvSpPr>
+        <p:spPr>
+          <a:xfrm>
+            <a:off x="10195560" y="4160520"/>
+            <a:ext cx="1325880" cy="384048"/>
+          </a:xfrm>
+          <a:prstGeom prst="rect">
+            <a:avLst/>
+          </a:prstGeom>
+          <a:noFill/>
+          <a:ln/>
+        </p:spPr>
+        <p:txBody>
+          <a:bodyPr wrap="square" lIns="0" tIns="0" rIns="0" bIns="0" rtlCol="0" anchor="ctr"/>
+          <a:lstStyle/>
+          <a:p>
+            <a:pPr indent="0" marL="0">
+              <a:buNone/>
+            </a:pPr>
+            <a:r>
+              <a:rPr lang="en-US" sz="950" dirty="0">
+                <a:solidFill>
+                  <a:srgbClr val="6E7480"/>
+                </a:solidFill>
+                <a:latin typeface="Calibri" pitchFamily="34" charset="0"/>
+                <a:ea typeface="Calibri" pitchFamily="34" charset="-122"/>
+                <a:cs typeface="Calibri" pitchFamily="34" charset="-120"/>
+              </a:rPr>
+              <a:t>required</a:t>
+            </a:r>
+            <a:endParaRPr lang="en-US" sz="950" dirty="0"/>
+          </a:p>
+        </p:txBody>
+      </p:sp>
+      <p:sp>
+        <p:nvSpPr>
+          <p:cNvPr id="44" name="Shape 42"/>
+          <p:cNvSpPr/>
+          <p:nvPr/>
+        </p:nvSpPr>
+        <p:spPr>
+          <a:xfrm>
+            <a:off x="548640" y="4937760"/>
+            <a:ext cx="11064240" cy="1463040"/>
+          </a:xfrm>
+          <a:prstGeom prst="roundRect">
+            <a:avLst>
+              <a:gd name="adj" fmla="val 5000"/>
+            </a:avLst>
+          </a:prstGeom>
+          <a:solidFill>
+            <a:srgbClr val="1F2A44"/>
+          </a:solidFill>
+          <a:ln/>
+        </p:spPr>
+      </p:sp>
+      <p:sp>
+        <p:nvSpPr>
+          <p:cNvPr id="45" name="Text 43"/>
+          <p:cNvSpPr/>
+          <p:nvPr/>
+        </p:nvSpPr>
+        <p:spPr>
+          <a:xfrm>
+            <a:off x="822960" y="5120640"/>
+            <a:ext cx="10515600" cy="1097280"/>
+          </a:xfrm>
+          <a:prstGeom prst="rect">
+            <a:avLst/>
+          </a:prstGeom>
+          <a:noFill/>
+          <a:ln/>
+        </p:spPr>
+        <p:txBody>
+          <a:bodyPr wrap="square" lIns="0" tIns="0" rIns="0" bIns="0" rtlCol="0" anchor="ctr"/>
+          <a:lstStyle/>
+          <a:p>
+            <a:pPr indent="0" marL="0">
+              <a:buNone/>
+            </a:pPr>
+            <a:r>
+              <a:rPr lang="en-US" sz="1300" b="1" dirty="0">
+                <a:solidFill>
+                  <a:srgbClr val="E3A94E"/>
+                </a:solidFill>
+                <a:latin typeface="Calibri" pitchFamily="34" charset="0"/>
+                <a:ea typeface="Calibri" pitchFamily="34" charset="-122"/>
+                <a:cs typeface="Calibri" pitchFamily="34" charset="-120"/>
+              </a:rPr>
+              <a:t>Recommendation: move forward, pending regulatory approval.  </a:t>
+            </a:r>
+            <a:pPr indent="0" marL="0">
+              <a:buNone/>
+            </a:pPr>
+            <a:r>
+              <a:rPr lang="en-US" sz="1300" dirty="0">
+                <a:solidFill>
+                  <a:srgbClr val="E8EBF2"/>
+                </a:solidFill>
+                <a:latin typeface="Calibri" pitchFamily="34" charset="0"/>
+                <a:ea typeface="Calibri" pitchFamily="34" charset="-122"/>
+                <a:cs typeface="Calibri" pitchFamily="34" charset="-120"/>
+              </a:rPr>
+              <a:t>What we learned: discipline is the deal. Price past a 30% premium and the same transaction fails two gates — dilution and earn-back. The model kept us honest: pay for the franchise, not the trophy.</a:t>
+            </a:r>
+            <a:endParaRPr lang="en-US" sz="1300" dirty="0"/>
+          </a:p>
+        </p:txBody>
+      </p:sp>
+    </p:spTree>
+  </p:cSld>
+  <p:clrMapOvr>
+    <a:masterClrMapping/>
+  </p:clrMapOvr>
+</p:sld>
+</file>
+
+<file path=ppt/slides/slide17.xml><?xml version="1.0" encoding="utf-8"?>
+<p:sld xmlns:a="http://schemas.openxmlformats.org/drawingml/2006/main" xmlns:r="http://schemas.openxmlformats.org/officeDocument/2006/relationships" xmlns:p="http://schemas.openxmlformats.org/presentationml/2006/main">
+  <p:cSld name="Slide 17">
+    <p:bg>
+      <p:bgPr>
+        <a:solidFill>
           <a:srgbClr val="141C31"/>
         </a:solidFill>
       </p:bgPr>

</xml_diff>